<commit_message>
Add Pydantic models and validation for prediction records
- Introduced `lesson_models.py` containing Pydantic models for predictions and batch configurations.
- Implemented validation logic for input records, including normalization and error handling.
- Created `check_contracts.py` for unit tests to ensure model integrity and validation correctness.
- Updated `README.md` with session details, execution instructions, and module usage.
- Added `NOTAS_DOCENTE.md` for teaching notes and session guidance.
- Included `requirements.txt` for dependency management with specific versions of Pydantic and mypy.
</commit_message>
<xml_diff>
--- a/unidad-01-python-moderno/semana-01-curso-acelerado-python/00_introduccion_programacion_ia.pptx
+++ b/unidad-01-python-moderno/semana-01-curso-acelerado-python/00_introduccion_programacion_ia.pptx
@@ -5285,20 +5285,20 @@
       </p:sp>
       <p:pic>
         <p:nvPicPr>
-          <p:cNvPr id="12" name=""/>
+          <p:cNvPr id="7" name=""/>
           <p:cNvPicPr>
             <a:picLocks xmlns:a="http://schemas.openxmlformats.org/drawingml/2006/main" noChangeAspect="1"/>
           </p:cNvPicPr>
           <p:nvPr/>
         </p:nvPicPr>
         <p:blipFill>
-          <a:blip xmlns:r="http://schemas.openxmlformats.org/officeDocument/2006/relationships" xmlns:a="http://schemas.openxmlformats.org/drawingml/2006/main" r:embed="Rdc2f5ac188594ee8"/>
+          <a:blip xmlns:r="http://schemas.openxmlformats.org/officeDocument/2006/relationships" xmlns:a="http://schemas.openxmlformats.org/drawingml/2006/main" r:embed="rIdFooter0"/>
           <a:stretch xmlns:a="http://schemas.openxmlformats.org/drawingml/2006/main"/>
         </p:blipFill>
         <p:spPr>
           <a:xfrm xmlns:a="http://schemas.openxmlformats.org/drawingml/2006/main">
-            <a:off x="390525" y="239911"/>
-            <a:ext cx="2095500" cy="1139428"/>
+            <a:off x="390525" y="6191250"/>
+            <a:ext cx="1000125" cy="542925"/>
           </a:xfrm>
           <a:prstGeom xmlns:a="http://schemas.openxmlformats.org/drawingml/2006/main" prst="rect">
             <a:avLst/>
@@ -5307,20 +5307,20 @@
       </p:pic>
       <p:pic>
         <p:nvPicPr>
-          <p:cNvPr id="13" name=""/>
+          <p:cNvPr id="8" name=""/>
           <p:cNvPicPr>
             <a:picLocks xmlns:a="http://schemas.openxmlformats.org/drawingml/2006/main" noChangeAspect="1"/>
           </p:cNvPicPr>
           <p:nvPr/>
         </p:nvPicPr>
         <p:blipFill>
-          <a:blip xmlns:r="http://schemas.openxmlformats.org/officeDocument/2006/relationships" xmlns:a="http://schemas.openxmlformats.org/drawingml/2006/main" r:embed="R7c29fda71d0b4a3a"/>
+          <a:blip xmlns:r="http://schemas.openxmlformats.org/officeDocument/2006/relationships" xmlns:a="http://schemas.openxmlformats.org/drawingml/2006/main" r:embed="rIdFooter1"/>
           <a:stretch xmlns:a="http://schemas.openxmlformats.org/drawingml/2006/main"/>
         </p:blipFill>
         <p:spPr>
           <a:xfrm xmlns:a="http://schemas.openxmlformats.org/drawingml/2006/main">
-            <a:off x="8680283" y="238125"/>
-            <a:ext cx="2737184" cy="1143000"/>
+            <a:off x="1666875" y="6191250"/>
+            <a:ext cx="1304925" cy="542925"/>
           </a:xfrm>
           <a:prstGeom xmlns:a="http://schemas.openxmlformats.org/drawingml/2006/main" prst="rect">
             <a:avLst/>
@@ -5884,6 +5884,50 @@
           </a:p>
         </p:txBody>
       </p:sp>
+      <p:pic>
+        <p:nvPicPr>
+          <p:cNvPr id="534" name=""/>
+          <p:cNvPicPr>
+            <a:picLocks xmlns:a="http://schemas.openxmlformats.org/drawingml/2006/main" noChangeAspect="1"/>
+          </p:cNvPicPr>
+          <p:nvPr/>
+        </p:nvPicPr>
+        <p:blipFill>
+          <a:blip xmlns:r="http://schemas.openxmlformats.org/officeDocument/2006/relationships" xmlns:a="http://schemas.openxmlformats.org/drawingml/2006/main" r:embed="rIdFooter0"/>
+          <a:stretch xmlns:a="http://schemas.openxmlformats.org/drawingml/2006/main"/>
+        </p:blipFill>
+        <p:spPr>
+          <a:xfrm xmlns:a="http://schemas.openxmlformats.org/drawingml/2006/main">
+            <a:off x="391346" y="6191250"/>
+            <a:ext cx="998483" cy="542925"/>
+          </a:xfrm>
+          <a:prstGeom xmlns:a="http://schemas.openxmlformats.org/drawingml/2006/main" prst="rect">
+            <a:avLst/>
+          </a:prstGeom>
+        </p:spPr>
+      </p:pic>
+      <p:pic>
+        <p:nvPicPr>
+          <p:cNvPr id="535" name=""/>
+          <p:cNvPicPr>
+            <a:picLocks xmlns:a="http://schemas.openxmlformats.org/drawingml/2006/main" noChangeAspect="1"/>
+          </p:cNvPicPr>
+          <p:nvPr/>
+        </p:nvPicPr>
+        <p:blipFill>
+          <a:blip xmlns:r="http://schemas.openxmlformats.org/officeDocument/2006/relationships" xmlns:a="http://schemas.openxmlformats.org/drawingml/2006/main" r:embed="rIdFooter1"/>
+          <a:stretch xmlns:a="http://schemas.openxmlformats.org/drawingml/2006/main"/>
+        </p:blipFill>
+        <p:spPr>
+          <a:xfrm xmlns:a="http://schemas.openxmlformats.org/drawingml/2006/main">
+            <a:off x="1669256" y="6191250"/>
+            <a:ext cx="1300163" cy="542925"/>
+          </a:xfrm>
+          <a:prstGeom xmlns:a="http://schemas.openxmlformats.org/drawingml/2006/main" prst="rect">
+            <a:avLst/>
+          </a:prstGeom>
+        </p:spPr>
+      </p:pic>
     </p:spTree>
     <p:extLst>
       <p:ext uri="{BB962C8B-B14F-4D97-AF65-F5344CB8AC3E}">
@@ -6233,6 +6277,50 @@
           </a:p>
         </p:txBody>
       </p:sp>
+      <p:pic>
+        <p:nvPicPr>
+          <p:cNvPr id="539" name=""/>
+          <p:cNvPicPr>
+            <a:picLocks xmlns:a="http://schemas.openxmlformats.org/drawingml/2006/main" noChangeAspect="1"/>
+          </p:cNvPicPr>
+          <p:nvPr/>
+        </p:nvPicPr>
+        <p:blipFill>
+          <a:blip xmlns:r="http://schemas.openxmlformats.org/officeDocument/2006/relationships" xmlns:a="http://schemas.openxmlformats.org/drawingml/2006/main" r:embed="rIdFooter0"/>
+          <a:stretch xmlns:a="http://schemas.openxmlformats.org/drawingml/2006/main"/>
+        </p:blipFill>
+        <p:spPr>
+          <a:xfrm xmlns:a="http://schemas.openxmlformats.org/drawingml/2006/main">
+            <a:off x="391346" y="6191250"/>
+            <a:ext cx="998483" cy="542925"/>
+          </a:xfrm>
+          <a:prstGeom xmlns:a="http://schemas.openxmlformats.org/drawingml/2006/main" prst="rect">
+            <a:avLst/>
+          </a:prstGeom>
+        </p:spPr>
+      </p:pic>
+      <p:pic>
+        <p:nvPicPr>
+          <p:cNvPr id="540" name=""/>
+          <p:cNvPicPr>
+            <a:picLocks xmlns:a="http://schemas.openxmlformats.org/drawingml/2006/main" noChangeAspect="1"/>
+          </p:cNvPicPr>
+          <p:nvPr/>
+        </p:nvPicPr>
+        <p:blipFill>
+          <a:blip xmlns:r="http://schemas.openxmlformats.org/officeDocument/2006/relationships" xmlns:a="http://schemas.openxmlformats.org/drawingml/2006/main" r:embed="rIdFooter1"/>
+          <a:stretch xmlns:a="http://schemas.openxmlformats.org/drawingml/2006/main"/>
+        </p:blipFill>
+        <p:spPr>
+          <a:xfrm xmlns:a="http://schemas.openxmlformats.org/drawingml/2006/main">
+            <a:off x="1669256" y="6191250"/>
+            <a:ext cx="1300163" cy="542925"/>
+          </a:xfrm>
+          <a:prstGeom xmlns:a="http://schemas.openxmlformats.org/drawingml/2006/main" prst="rect">
+            <a:avLst/>
+          </a:prstGeom>
+        </p:spPr>
+      </p:pic>
     </p:spTree>
     <p:extLst>
       <p:ext uri="{BB962C8B-B14F-4D97-AF65-F5344CB8AC3E}">
@@ -6805,6 +6893,50 @@
           </a:p>
         </p:txBody>
       </p:sp>
+      <p:pic>
+        <p:nvPicPr>
+          <p:cNvPr id="12" name=""/>
+          <p:cNvPicPr>
+            <a:picLocks xmlns:a="http://schemas.openxmlformats.org/drawingml/2006/main" noChangeAspect="1"/>
+          </p:cNvPicPr>
+          <p:nvPr/>
+        </p:nvPicPr>
+        <p:blipFill>
+          <a:blip xmlns:r="http://schemas.openxmlformats.org/officeDocument/2006/relationships" xmlns:a="http://schemas.openxmlformats.org/drawingml/2006/main" r:embed="rIdFooter0"/>
+          <a:stretch xmlns:a="http://schemas.openxmlformats.org/drawingml/2006/main"/>
+        </p:blipFill>
+        <p:spPr>
+          <a:xfrm xmlns:a="http://schemas.openxmlformats.org/drawingml/2006/main">
+            <a:off x="391346" y="6191250"/>
+            <a:ext cx="998483" cy="542925"/>
+          </a:xfrm>
+          <a:prstGeom xmlns:a="http://schemas.openxmlformats.org/drawingml/2006/main" prst="rect">
+            <a:avLst/>
+          </a:prstGeom>
+        </p:spPr>
+      </p:pic>
+      <p:pic>
+        <p:nvPicPr>
+          <p:cNvPr id="13" name=""/>
+          <p:cNvPicPr>
+            <a:picLocks xmlns:a="http://schemas.openxmlformats.org/drawingml/2006/main" noChangeAspect="1"/>
+          </p:cNvPicPr>
+          <p:nvPr/>
+        </p:nvPicPr>
+        <p:blipFill>
+          <a:blip xmlns:r="http://schemas.openxmlformats.org/officeDocument/2006/relationships" xmlns:a="http://schemas.openxmlformats.org/drawingml/2006/main" r:embed="rIdFooter1"/>
+          <a:stretch xmlns:a="http://schemas.openxmlformats.org/drawingml/2006/main"/>
+        </p:blipFill>
+        <p:spPr>
+          <a:xfrm xmlns:a="http://schemas.openxmlformats.org/drawingml/2006/main">
+            <a:off x="1669256" y="6191250"/>
+            <a:ext cx="1300163" cy="542925"/>
+          </a:xfrm>
+          <a:prstGeom xmlns:a="http://schemas.openxmlformats.org/drawingml/2006/main" prst="rect">
+            <a:avLst/>
+          </a:prstGeom>
+        </p:spPr>
+      </p:pic>
     </p:spTree>
     <p:extLst>
       <p:ext uri="{BB962C8B-B14F-4D97-AF65-F5344CB8AC3E}">
@@ -7450,6 +7582,50 @@
           </a:p>
         </p:txBody>
       </p:sp>
+      <p:pic>
+        <p:nvPicPr>
+          <p:cNvPr id="534" name=""/>
+          <p:cNvPicPr>
+            <a:picLocks xmlns:a="http://schemas.openxmlformats.org/drawingml/2006/main" noChangeAspect="1"/>
+          </p:cNvPicPr>
+          <p:nvPr/>
+        </p:nvPicPr>
+        <p:blipFill>
+          <a:blip xmlns:r="http://schemas.openxmlformats.org/officeDocument/2006/relationships" xmlns:a="http://schemas.openxmlformats.org/drawingml/2006/main" r:embed="rIdFooter0"/>
+          <a:stretch xmlns:a="http://schemas.openxmlformats.org/drawingml/2006/main"/>
+        </p:blipFill>
+        <p:spPr>
+          <a:xfrm xmlns:a="http://schemas.openxmlformats.org/drawingml/2006/main">
+            <a:off x="391346" y="6191250"/>
+            <a:ext cx="998483" cy="542925"/>
+          </a:xfrm>
+          <a:prstGeom xmlns:a="http://schemas.openxmlformats.org/drawingml/2006/main" prst="rect">
+            <a:avLst/>
+          </a:prstGeom>
+        </p:spPr>
+      </p:pic>
+      <p:pic>
+        <p:nvPicPr>
+          <p:cNvPr id="535" name=""/>
+          <p:cNvPicPr>
+            <a:picLocks xmlns:a="http://schemas.openxmlformats.org/drawingml/2006/main" noChangeAspect="1"/>
+          </p:cNvPicPr>
+          <p:nvPr/>
+        </p:nvPicPr>
+        <p:blipFill>
+          <a:blip xmlns:r="http://schemas.openxmlformats.org/officeDocument/2006/relationships" xmlns:a="http://schemas.openxmlformats.org/drawingml/2006/main" r:embed="rIdFooter1"/>
+          <a:stretch xmlns:a="http://schemas.openxmlformats.org/drawingml/2006/main"/>
+        </p:blipFill>
+        <p:spPr>
+          <a:xfrm xmlns:a="http://schemas.openxmlformats.org/drawingml/2006/main">
+            <a:off x="1669256" y="6191250"/>
+            <a:ext cx="1300163" cy="542925"/>
+          </a:xfrm>
+          <a:prstGeom xmlns:a="http://schemas.openxmlformats.org/drawingml/2006/main" prst="rect">
+            <a:avLst/>
+          </a:prstGeom>
+        </p:spPr>
+      </p:pic>
     </p:spTree>
     <p:extLst>
       <p:ext uri="{BB962C8B-B14F-4D97-AF65-F5344CB8AC3E}">
@@ -8073,6 +8249,50 @@
           </a:p>
         </p:txBody>
       </p:sp>
+      <p:pic>
+        <p:nvPicPr>
+          <p:cNvPr id="534" name=""/>
+          <p:cNvPicPr>
+            <a:picLocks xmlns:a="http://schemas.openxmlformats.org/drawingml/2006/main" noChangeAspect="1"/>
+          </p:cNvPicPr>
+          <p:nvPr/>
+        </p:nvPicPr>
+        <p:blipFill>
+          <a:blip xmlns:r="http://schemas.openxmlformats.org/officeDocument/2006/relationships" xmlns:a="http://schemas.openxmlformats.org/drawingml/2006/main" r:embed="rIdFooter0"/>
+          <a:stretch xmlns:a="http://schemas.openxmlformats.org/drawingml/2006/main"/>
+        </p:blipFill>
+        <p:spPr>
+          <a:xfrm xmlns:a="http://schemas.openxmlformats.org/drawingml/2006/main">
+            <a:off x="391346" y="6191250"/>
+            <a:ext cx="998483" cy="542925"/>
+          </a:xfrm>
+          <a:prstGeom xmlns:a="http://schemas.openxmlformats.org/drawingml/2006/main" prst="rect">
+            <a:avLst/>
+          </a:prstGeom>
+        </p:spPr>
+      </p:pic>
+      <p:pic>
+        <p:nvPicPr>
+          <p:cNvPr id="535" name=""/>
+          <p:cNvPicPr>
+            <a:picLocks xmlns:a="http://schemas.openxmlformats.org/drawingml/2006/main" noChangeAspect="1"/>
+          </p:cNvPicPr>
+          <p:nvPr/>
+        </p:nvPicPr>
+        <p:blipFill>
+          <a:blip xmlns:r="http://schemas.openxmlformats.org/officeDocument/2006/relationships" xmlns:a="http://schemas.openxmlformats.org/drawingml/2006/main" r:embed="rIdFooter1"/>
+          <a:stretch xmlns:a="http://schemas.openxmlformats.org/drawingml/2006/main"/>
+        </p:blipFill>
+        <p:spPr>
+          <a:xfrm xmlns:a="http://schemas.openxmlformats.org/drawingml/2006/main">
+            <a:off x="1669256" y="6191250"/>
+            <a:ext cx="1300163" cy="542925"/>
+          </a:xfrm>
+          <a:prstGeom xmlns:a="http://schemas.openxmlformats.org/drawingml/2006/main" prst="rect">
+            <a:avLst/>
+          </a:prstGeom>
+        </p:spPr>
+      </p:pic>
     </p:spTree>
     <p:extLst>
       <p:ext uri="{BB962C8B-B14F-4D97-AF65-F5344CB8AC3E}">
@@ -8564,6 +8784,50 @@
           </a:p>
         </p:txBody>
       </p:sp>
+      <p:pic>
+        <p:nvPicPr>
+          <p:cNvPr id="534" name=""/>
+          <p:cNvPicPr>
+            <a:picLocks xmlns:a="http://schemas.openxmlformats.org/drawingml/2006/main" noChangeAspect="1"/>
+          </p:cNvPicPr>
+          <p:nvPr/>
+        </p:nvPicPr>
+        <p:blipFill>
+          <a:blip xmlns:r="http://schemas.openxmlformats.org/officeDocument/2006/relationships" xmlns:a="http://schemas.openxmlformats.org/drawingml/2006/main" r:embed="rIdFooter0"/>
+          <a:stretch xmlns:a="http://schemas.openxmlformats.org/drawingml/2006/main"/>
+        </p:blipFill>
+        <p:spPr>
+          <a:xfrm xmlns:a="http://schemas.openxmlformats.org/drawingml/2006/main">
+            <a:off x="391346" y="6191250"/>
+            <a:ext cx="998483" cy="542925"/>
+          </a:xfrm>
+          <a:prstGeom xmlns:a="http://schemas.openxmlformats.org/drawingml/2006/main" prst="rect">
+            <a:avLst/>
+          </a:prstGeom>
+        </p:spPr>
+      </p:pic>
+      <p:pic>
+        <p:nvPicPr>
+          <p:cNvPr id="535" name=""/>
+          <p:cNvPicPr>
+            <a:picLocks xmlns:a="http://schemas.openxmlformats.org/drawingml/2006/main" noChangeAspect="1"/>
+          </p:cNvPicPr>
+          <p:nvPr/>
+        </p:nvPicPr>
+        <p:blipFill>
+          <a:blip xmlns:r="http://schemas.openxmlformats.org/officeDocument/2006/relationships" xmlns:a="http://schemas.openxmlformats.org/drawingml/2006/main" r:embed="rIdFooter1"/>
+          <a:stretch xmlns:a="http://schemas.openxmlformats.org/drawingml/2006/main"/>
+        </p:blipFill>
+        <p:spPr>
+          <a:xfrm xmlns:a="http://schemas.openxmlformats.org/drawingml/2006/main">
+            <a:off x="1669256" y="6191250"/>
+            <a:ext cx="1300163" cy="542925"/>
+          </a:xfrm>
+          <a:prstGeom xmlns:a="http://schemas.openxmlformats.org/drawingml/2006/main" prst="rect">
+            <a:avLst/>
+          </a:prstGeom>
+        </p:spPr>
+      </p:pic>
     </p:spTree>
     <p:extLst>
       <p:ext uri="{BB962C8B-B14F-4D97-AF65-F5344CB8AC3E}">
@@ -9176,6 +9440,50 @@
           </a:p>
         </p:txBody>
       </p:sp>
+      <p:pic>
+        <p:nvPicPr>
+          <p:cNvPr id="534" name=""/>
+          <p:cNvPicPr>
+            <a:picLocks xmlns:a="http://schemas.openxmlformats.org/drawingml/2006/main" noChangeAspect="1"/>
+          </p:cNvPicPr>
+          <p:nvPr/>
+        </p:nvPicPr>
+        <p:blipFill>
+          <a:blip xmlns:r="http://schemas.openxmlformats.org/officeDocument/2006/relationships" xmlns:a="http://schemas.openxmlformats.org/drawingml/2006/main" r:embed="rIdFooter0"/>
+          <a:stretch xmlns:a="http://schemas.openxmlformats.org/drawingml/2006/main"/>
+        </p:blipFill>
+        <p:spPr>
+          <a:xfrm xmlns:a="http://schemas.openxmlformats.org/drawingml/2006/main">
+            <a:off x="391346" y="6191250"/>
+            <a:ext cx="998483" cy="542925"/>
+          </a:xfrm>
+          <a:prstGeom xmlns:a="http://schemas.openxmlformats.org/drawingml/2006/main" prst="rect">
+            <a:avLst/>
+          </a:prstGeom>
+        </p:spPr>
+      </p:pic>
+      <p:pic>
+        <p:nvPicPr>
+          <p:cNvPr id="535" name=""/>
+          <p:cNvPicPr>
+            <a:picLocks xmlns:a="http://schemas.openxmlformats.org/drawingml/2006/main" noChangeAspect="1"/>
+          </p:cNvPicPr>
+          <p:nvPr/>
+        </p:nvPicPr>
+        <p:blipFill>
+          <a:blip xmlns:r="http://schemas.openxmlformats.org/officeDocument/2006/relationships" xmlns:a="http://schemas.openxmlformats.org/drawingml/2006/main" r:embed="rIdFooter1"/>
+          <a:stretch xmlns:a="http://schemas.openxmlformats.org/drawingml/2006/main"/>
+        </p:blipFill>
+        <p:spPr>
+          <a:xfrm xmlns:a="http://schemas.openxmlformats.org/drawingml/2006/main">
+            <a:off x="1669256" y="6191250"/>
+            <a:ext cx="1300163" cy="542925"/>
+          </a:xfrm>
+          <a:prstGeom xmlns:a="http://schemas.openxmlformats.org/drawingml/2006/main" prst="rect">
+            <a:avLst/>
+          </a:prstGeom>
+        </p:spPr>
+      </p:pic>
     </p:spTree>
     <p:extLst>
       <p:ext uri="{BB962C8B-B14F-4D97-AF65-F5344CB8AC3E}">
@@ -9748,6 +10056,50 @@
           </a:p>
         </p:txBody>
       </p:sp>
+      <p:pic>
+        <p:nvPicPr>
+          <p:cNvPr id="12" name=""/>
+          <p:cNvPicPr>
+            <a:picLocks xmlns:a="http://schemas.openxmlformats.org/drawingml/2006/main" noChangeAspect="1"/>
+          </p:cNvPicPr>
+          <p:nvPr/>
+        </p:nvPicPr>
+        <p:blipFill>
+          <a:blip xmlns:r="http://schemas.openxmlformats.org/officeDocument/2006/relationships" xmlns:a="http://schemas.openxmlformats.org/drawingml/2006/main" r:embed="rIdFooter0"/>
+          <a:stretch xmlns:a="http://schemas.openxmlformats.org/drawingml/2006/main"/>
+        </p:blipFill>
+        <p:spPr>
+          <a:xfrm xmlns:a="http://schemas.openxmlformats.org/drawingml/2006/main">
+            <a:off x="391346" y="6191250"/>
+            <a:ext cx="998483" cy="542925"/>
+          </a:xfrm>
+          <a:prstGeom xmlns:a="http://schemas.openxmlformats.org/drawingml/2006/main" prst="rect">
+            <a:avLst/>
+          </a:prstGeom>
+        </p:spPr>
+      </p:pic>
+      <p:pic>
+        <p:nvPicPr>
+          <p:cNvPr id="13" name=""/>
+          <p:cNvPicPr>
+            <a:picLocks xmlns:a="http://schemas.openxmlformats.org/drawingml/2006/main" noChangeAspect="1"/>
+          </p:cNvPicPr>
+          <p:nvPr/>
+        </p:nvPicPr>
+        <p:blipFill>
+          <a:blip xmlns:r="http://schemas.openxmlformats.org/officeDocument/2006/relationships" xmlns:a="http://schemas.openxmlformats.org/drawingml/2006/main" r:embed="rIdFooter1"/>
+          <a:stretch xmlns:a="http://schemas.openxmlformats.org/drawingml/2006/main"/>
+        </p:blipFill>
+        <p:spPr>
+          <a:xfrm xmlns:a="http://schemas.openxmlformats.org/drawingml/2006/main">
+            <a:off x="1669256" y="6191250"/>
+            <a:ext cx="1300163" cy="542925"/>
+          </a:xfrm>
+          <a:prstGeom xmlns:a="http://schemas.openxmlformats.org/drawingml/2006/main" prst="rect">
+            <a:avLst/>
+          </a:prstGeom>
+        </p:spPr>
+      </p:pic>
     </p:spTree>
     <p:extLst>
       <p:ext uri="{BB962C8B-B14F-4D97-AF65-F5344CB8AC3E}">
@@ -10294,6 +10646,50 @@
           </a:p>
         </p:txBody>
       </p:sp>
+      <p:pic>
+        <p:nvPicPr>
+          <p:cNvPr id="534" name=""/>
+          <p:cNvPicPr>
+            <a:picLocks xmlns:a="http://schemas.openxmlformats.org/drawingml/2006/main" noChangeAspect="1"/>
+          </p:cNvPicPr>
+          <p:nvPr/>
+        </p:nvPicPr>
+        <p:blipFill>
+          <a:blip xmlns:r="http://schemas.openxmlformats.org/officeDocument/2006/relationships" xmlns:a="http://schemas.openxmlformats.org/drawingml/2006/main" r:embed="rIdFooter0"/>
+          <a:stretch xmlns:a="http://schemas.openxmlformats.org/drawingml/2006/main"/>
+        </p:blipFill>
+        <p:spPr>
+          <a:xfrm xmlns:a="http://schemas.openxmlformats.org/drawingml/2006/main">
+            <a:off x="391346" y="6191250"/>
+            <a:ext cx="998483" cy="542925"/>
+          </a:xfrm>
+          <a:prstGeom xmlns:a="http://schemas.openxmlformats.org/drawingml/2006/main" prst="rect">
+            <a:avLst/>
+          </a:prstGeom>
+        </p:spPr>
+      </p:pic>
+      <p:pic>
+        <p:nvPicPr>
+          <p:cNvPr id="535" name=""/>
+          <p:cNvPicPr>
+            <a:picLocks xmlns:a="http://schemas.openxmlformats.org/drawingml/2006/main" noChangeAspect="1"/>
+          </p:cNvPicPr>
+          <p:nvPr/>
+        </p:nvPicPr>
+        <p:blipFill>
+          <a:blip xmlns:r="http://schemas.openxmlformats.org/officeDocument/2006/relationships" xmlns:a="http://schemas.openxmlformats.org/drawingml/2006/main" r:embed="rIdFooter1"/>
+          <a:stretch xmlns:a="http://schemas.openxmlformats.org/drawingml/2006/main"/>
+        </p:blipFill>
+        <p:spPr>
+          <a:xfrm xmlns:a="http://schemas.openxmlformats.org/drawingml/2006/main">
+            <a:off x="1669256" y="6191250"/>
+            <a:ext cx="1300163" cy="542925"/>
+          </a:xfrm>
+          <a:prstGeom xmlns:a="http://schemas.openxmlformats.org/drawingml/2006/main" prst="rect">
+            <a:avLst/>
+          </a:prstGeom>
+        </p:spPr>
+      </p:pic>
     </p:spTree>
     <p:extLst>
       <p:ext uri="{BB962C8B-B14F-4D97-AF65-F5344CB8AC3E}">
@@ -10591,50 +10987,6 @@
       </p:sp>
       <p:pic>
         <p:nvPicPr>
-          <p:cNvPr id="13" name=""/>
-          <p:cNvPicPr>
-            <a:picLocks xmlns:a="http://schemas.openxmlformats.org/drawingml/2006/main" noChangeAspect="1"/>
-          </p:cNvPicPr>
-          <p:nvPr/>
-        </p:nvPicPr>
-        <p:blipFill>
-          <a:blip xmlns:r="http://schemas.openxmlformats.org/officeDocument/2006/relationships" xmlns:a="http://schemas.openxmlformats.org/drawingml/2006/main" r:embed="R7aaed2df3d6f4506"/>
-          <a:stretch xmlns:a="http://schemas.openxmlformats.org/drawingml/2006/main"/>
-        </p:blipFill>
-        <p:spPr>
-          <a:xfrm xmlns:a="http://schemas.openxmlformats.org/drawingml/2006/main">
-            <a:off x="390525" y="239911"/>
-            <a:ext cx="2095500" cy="1139428"/>
-          </a:xfrm>
-          <a:prstGeom xmlns:a="http://schemas.openxmlformats.org/drawingml/2006/main" prst="rect">
-            <a:avLst/>
-          </a:prstGeom>
-        </p:spPr>
-      </p:pic>
-      <p:pic>
-        <p:nvPicPr>
-          <p:cNvPr id="14" name=""/>
-          <p:cNvPicPr>
-            <a:picLocks xmlns:a="http://schemas.openxmlformats.org/drawingml/2006/main" noChangeAspect="1"/>
-          </p:cNvPicPr>
-          <p:nvPr/>
-        </p:nvPicPr>
-        <p:blipFill>
-          <a:blip xmlns:r="http://schemas.openxmlformats.org/officeDocument/2006/relationships" xmlns:a="http://schemas.openxmlformats.org/drawingml/2006/main" r:embed="Rf8de47e1a31b4b00"/>
-          <a:stretch xmlns:a="http://schemas.openxmlformats.org/drawingml/2006/main"/>
-        </p:blipFill>
-        <p:spPr>
-          <a:xfrm xmlns:a="http://schemas.openxmlformats.org/drawingml/2006/main">
-            <a:off x="8680283" y="238125"/>
-            <a:ext cx="2737184" cy="1143000"/>
-          </a:xfrm>
-          <a:prstGeom xmlns:a="http://schemas.openxmlformats.org/drawingml/2006/main" prst="rect">
-            <a:avLst/>
-          </a:prstGeom>
-        </p:spPr>
-      </p:pic>
-      <p:pic>
-        <p:nvPicPr>
           <p:cNvPr id="15" name=""/>
           <p:cNvPicPr>
             <a:picLocks xmlns:a="http://schemas.openxmlformats.org/drawingml/2006/main" noChangeAspect="1"/>
@@ -10649,6 +11001,50 @@
           <a:xfrm xmlns:a="http://schemas.openxmlformats.org/drawingml/2006/main">
             <a:off x="9715500" y="4524375"/>
             <a:ext cx="1571625" cy="1571625"/>
+          </a:xfrm>
+          <a:prstGeom xmlns:a="http://schemas.openxmlformats.org/drawingml/2006/main" prst="rect">
+            <a:avLst/>
+          </a:prstGeom>
+        </p:spPr>
+      </p:pic>
+      <p:pic>
+        <p:nvPicPr>
+          <p:cNvPr id="16" name=""/>
+          <p:cNvPicPr>
+            <a:picLocks xmlns:a="http://schemas.openxmlformats.org/drawingml/2006/main" noChangeAspect="1"/>
+          </p:cNvPicPr>
+          <p:nvPr/>
+        </p:nvPicPr>
+        <p:blipFill>
+          <a:blip xmlns:r="http://schemas.openxmlformats.org/officeDocument/2006/relationships" xmlns:a="http://schemas.openxmlformats.org/drawingml/2006/main" r:embed="rIdFooter0"/>
+          <a:stretch xmlns:a="http://schemas.openxmlformats.org/drawingml/2006/main"/>
+        </p:blipFill>
+        <p:spPr>
+          <a:xfrm xmlns:a="http://schemas.openxmlformats.org/drawingml/2006/main">
+            <a:off x="390525" y="6191250"/>
+            <a:ext cx="1000125" cy="542925"/>
+          </a:xfrm>
+          <a:prstGeom xmlns:a="http://schemas.openxmlformats.org/drawingml/2006/main" prst="rect">
+            <a:avLst/>
+          </a:prstGeom>
+        </p:spPr>
+      </p:pic>
+      <p:pic>
+        <p:nvPicPr>
+          <p:cNvPr id="17" name=""/>
+          <p:cNvPicPr>
+            <a:picLocks xmlns:a="http://schemas.openxmlformats.org/drawingml/2006/main" noChangeAspect="1"/>
+          </p:cNvPicPr>
+          <p:nvPr/>
+        </p:nvPicPr>
+        <p:blipFill>
+          <a:blip xmlns:r="http://schemas.openxmlformats.org/officeDocument/2006/relationships" xmlns:a="http://schemas.openxmlformats.org/drawingml/2006/main" r:embed="rIdFooter1"/>
+          <a:stretch xmlns:a="http://schemas.openxmlformats.org/drawingml/2006/main"/>
+        </p:blipFill>
+        <p:spPr>
+          <a:xfrm xmlns:a="http://schemas.openxmlformats.org/drawingml/2006/main">
+            <a:off x="1666875" y="6191250"/>
+            <a:ext cx="1304925" cy="542925"/>
           </a:xfrm>
           <a:prstGeom xmlns:a="http://schemas.openxmlformats.org/drawingml/2006/main" prst="rect">
             <a:avLst/>
@@ -11036,6 +11432,50 @@
           </a:p>
         </p:txBody>
       </p:sp>
+      <p:pic>
+        <p:nvPicPr>
+          <p:cNvPr id="534" name=""/>
+          <p:cNvPicPr>
+            <a:picLocks xmlns:a="http://schemas.openxmlformats.org/drawingml/2006/main" noChangeAspect="1"/>
+          </p:cNvPicPr>
+          <p:nvPr/>
+        </p:nvPicPr>
+        <p:blipFill>
+          <a:blip xmlns:r="http://schemas.openxmlformats.org/officeDocument/2006/relationships" xmlns:a="http://schemas.openxmlformats.org/drawingml/2006/main" r:embed="rIdFooter0"/>
+          <a:stretch xmlns:a="http://schemas.openxmlformats.org/drawingml/2006/main"/>
+        </p:blipFill>
+        <p:spPr>
+          <a:xfrm xmlns:a="http://schemas.openxmlformats.org/drawingml/2006/main">
+            <a:off x="391346" y="6191250"/>
+            <a:ext cx="998483" cy="542925"/>
+          </a:xfrm>
+          <a:prstGeom xmlns:a="http://schemas.openxmlformats.org/drawingml/2006/main" prst="rect">
+            <a:avLst/>
+          </a:prstGeom>
+        </p:spPr>
+      </p:pic>
+      <p:pic>
+        <p:nvPicPr>
+          <p:cNvPr id="535" name=""/>
+          <p:cNvPicPr>
+            <a:picLocks xmlns:a="http://schemas.openxmlformats.org/drawingml/2006/main" noChangeAspect="1"/>
+          </p:cNvPicPr>
+          <p:nvPr/>
+        </p:nvPicPr>
+        <p:blipFill>
+          <a:blip xmlns:r="http://schemas.openxmlformats.org/officeDocument/2006/relationships" xmlns:a="http://schemas.openxmlformats.org/drawingml/2006/main" r:embed="rIdFooter1"/>
+          <a:stretch xmlns:a="http://schemas.openxmlformats.org/drawingml/2006/main"/>
+        </p:blipFill>
+        <p:spPr>
+          <a:xfrm xmlns:a="http://schemas.openxmlformats.org/drawingml/2006/main">
+            <a:off x="1669256" y="6191250"/>
+            <a:ext cx="1300163" cy="542925"/>
+          </a:xfrm>
+          <a:prstGeom xmlns:a="http://schemas.openxmlformats.org/drawingml/2006/main" prst="rect">
+            <a:avLst/>
+          </a:prstGeom>
+        </p:spPr>
+      </p:pic>
     </p:spTree>
     <p:extLst>
       <p:ext uri="{BB962C8B-B14F-4D97-AF65-F5344CB8AC3E}">
@@ -11608,6 +12048,50 @@
           </a:p>
         </p:txBody>
       </p:sp>
+      <p:pic>
+        <p:nvPicPr>
+          <p:cNvPr id="12" name=""/>
+          <p:cNvPicPr>
+            <a:picLocks xmlns:a="http://schemas.openxmlformats.org/drawingml/2006/main" noChangeAspect="1"/>
+          </p:cNvPicPr>
+          <p:nvPr/>
+        </p:nvPicPr>
+        <p:blipFill>
+          <a:blip xmlns:r="http://schemas.openxmlformats.org/officeDocument/2006/relationships" xmlns:a="http://schemas.openxmlformats.org/drawingml/2006/main" r:embed="rIdFooter0"/>
+          <a:stretch xmlns:a="http://schemas.openxmlformats.org/drawingml/2006/main"/>
+        </p:blipFill>
+        <p:spPr>
+          <a:xfrm xmlns:a="http://schemas.openxmlformats.org/drawingml/2006/main">
+            <a:off x="391346" y="6191250"/>
+            <a:ext cx="998483" cy="542925"/>
+          </a:xfrm>
+          <a:prstGeom xmlns:a="http://schemas.openxmlformats.org/drawingml/2006/main" prst="rect">
+            <a:avLst/>
+          </a:prstGeom>
+        </p:spPr>
+      </p:pic>
+      <p:pic>
+        <p:nvPicPr>
+          <p:cNvPr id="13" name=""/>
+          <p:cNvPicPr>
+            <a:picLocks xmlns:a="http://schemas.openxmlformats.org/drawingml/2006/main" noChangeAspect="1"/>
+          </p:cNvPicPr>
+          <p:nvPr/>
+        </p:nvPicPr>
+        <p:blipFill>
+          <a:blip xmlns:r="http://schemas.openxmlformats.org/officeDocument/2006/relationships" xmlns:a="http://schemas.openxmlformats.org/drawingml/2006/main" r:embed="rIdFooter1"/>
+          <a:stretch xmlns:a="http://schemas.openxmlformats.org/drawingml/2006/main"/>
+        </p:blipFill>
+        <p:spPr>
+          <a:xfrm xmlns:a="http://schemas.openxmlformats.org/drawingml/2006/main">
+            <a:off x="1669256" y="6191250"/>
+            <a:ext cx="1300163" cy="542925"/>
+          </a:xfrm>
+          <a:prstGeom xmlns:a="http://schemas.openxmlformats.org/drawingml/2006/main" prst="rect">
+            <a:avLst/>
+          </a:prstGeom>
+        </p:spPr>
+      </p:pic>
     </p:spTree>
     <p:extLst>
       <p:ext uri="{BB962C8B-B14F-4D97-AF65-F5344CB8AC3E}">
@@ -12180,6 +12664,50 @@
           </a:p>
         </p:txBody>
       </p:sp>
+      <p:pic>
+        <p:nvPicPr>
+          <p:cNvPr id="12" name=""/>
+          <p:cNvPicPr>
+            <a:picLocks xmlns:a="http://schemas.openxmlformats.org/drawingml/2006/main" noChangeAspect="1"/>
+          </p:cNvPicPr>
+          <p:nvPr/>
+        </p:nvPicPr>
+        <p:blipFill>
+          <a:blip xmlns:r="http://schemas.openxmlformats.org/officeDocument/2006/relationships" xmlns:a="http://schemas.openxmlformats.org/drawingml/2006/main" r:embed="rIdFooter0"/>
+          <a:stretch xmlns:a="http://schemas.openxmlformats.org/drawingml/2006/main"/>
+        </p:blipFill>
+        <p:spPr>
+          <a:xfrm xmlns:a="http://schemas.openxmlformats.org/drawingml/2006/main">
+            <a:off x="391346" y="6191250"/>
+            <a:ext cx="998483" cy="542925"/>
+          </a:xfrm>
+          <a:prstGeom xmlns:a="http://schemas.openxmlformats.org/drawingml/2006/main" prst="rect">
+            <a:avLst/>
+          </a:prstGeom>
+        </p:spPr>
+      </p:pic>
+      <p:pic>
+        <p:nvPicPr>
+          <p:cNvPr id="13" name=""/>
+          <p:cNvPicPr>
+            <a:picLocks xmlns:a="http://schemas.openxmlformats.org/drawingml/2006/main" noChangeAspect="1"/>
+          </p:cNvPicPr>
+          <p:nvPr/>
+        </p:nvPicPr>
+        <p:blipFill>
+          <a:blip xmlns:r="http://schemas.openxmlformats.org/officeDocument/2006/relationships" xmlns:a="http://schemas.openxmlformats.org/drawingml/2006/main" r:embed="rIdFooter1"/>
+          <a:stretch xmlns:a="http://schemas.openxmlformats.org/drawingml/2006/main"/>
+        </p:blipFill>
+        <p:spPr>
+          <a:xfrm xmlns:a="http://schemas.openxmlformats.org/drawingml/2006/main">
+            <a:off x="1669256" y="6191250"/>
+            <a:ext cx="1300163" cy="542925"/>
+          </a:xfrm>
+          <a:prstGeom xmlns:a="http://schemas.openxmlformats.org/drawingml/2006/main" prst="rect">
+            <a:avLst/>
+          </a:prstGeom>
+        </p:spPr>
+      </p:pic>
     </p:spTree>
     <p:extLst>
       <p:ext uri="{BB962C8B-B14F-4D97-AF65-F5344CB8AC3E}">
@@ -12790,6 +13318,50 @@
           <a:xfrm xmlns:a="http://schemas.openxmlformats.org/drawingml/2006/main">
             <a:off x="6257925" y="1528189"/>
             <a:ext cx="2333625" cy="944123"/>
+          </a:xfrm>
+          <a:prstGeom xmlns:a="http://schemas.openxmlformats.org/drawingml/2006/main" prst="rect">
+            <a:avLst/>
+          </a:prstGeom>
+        </p:spPr>
+      </p:pic>
+      <p:pic>
+        <p:nvPicPr>
+          <p:cNvPr id="23" name=""/>
+          <p:cNvPicPr>
+            <a:picLocks xmlns:a="http://schemas.openxmlformats.org/drawingml/2006/main" noChangeAspect="1"/>
+          </p:cNvPicPr>
+          <p:nvPr/>
+        </p:nvPicPr>
+        <p:blipFill>
+          <a:blip xmlns:r="http://schemas.openxmlformats.org/officeDocument/2006/relationships" xmlns:a="http://schemas.openxmlformats.org/drawingml/2006/main" r:embed="rIdFooter0"/>
+          <a:stretch xmlns:a="http://schemas.openxmlformats.org/drawingml/2006/main"/>
+        </p:blipFill>
+        <p:spPr>
+          <a:xfrm xmlns:a="http://schemas.openxmlformats.org/drawingml/2006/main">
+            <a:off x="391346" y="6191250"/>
+            <a:ext cx="998483" cy="542925"/>
+          </a:xfrm>
+          <a:prstGeom xmlns:a="http://schemas.openxmlformats.org/drawingml/2006/main" prst="rect">
+            <a:avLst/>
+          </a:prstGeom>
+        </p:spPr>
+      </p:pic>
+      <p:pic>
+        <p:nvPicPr>
+          <p:cNvPr id="24" name=""/>
+          <p:cNvPicPr>
+            <a:picLocks xmlns:a="http://schemas.openxmlformats.org/drawingml/2006/main" noChangeAspect="1"/>
+          </p:cNvPicPr>
+          <p:nvPr/>
+        </p:nvPicPr>
+        <p:blipFill>
+          <a:blip xmlns:r="http://schemas.openxmlformats.org/officeDocument/2006/relationships" xmlns:a="http://schemas.openxmlformats.org/drawingml/2006/main" r:embed="rIdFooter1"/>
+          <a:stretch xmlns:a="http://schemas.openxmlformats.org/drawingml/2006/main"/>
+        </p:blipFill>
+        <p:spPr>
+          <a:xfrm xmlns:a="http://schemas.openxmlformats.org/drawingml/2006/main">
+            <a:off x="1669256" y="6191250"/>
+            <a:ext cx="1300163" cy="542925"/>
           </a:xfrm>
           <a:prstGeom xmlns:a="http://schemas.openxmlformats.org/drawingml/2006/main" prst="rect">
             <a:avLst/>
@@ -13412,6 +13984,50 @@
           </a:prstGeom>
         </p:spPr>
       </p:pic>
+      <p:pic>
+        <p:nvPicPr>
+          <p:cNvPr id="23" name=""/>
+          <p:cNvPicPr>
+            <a:picLocks xmlns:a="http://schemas.openxmlformats.org/drawingml/2006/main" noChangeAspect="1"/>
+          </p:cNvPicPr>
+          <p:nvPr/>
+        </p:nvPicPr>
+        <p:blipFill>
+          <a:blip xmlns:r="http://schemas.openxmlformats.org/officeDocument/2006/relationships" xmlns:a="http://schemas.openxmlformats.org/drawingml/2006/main" r:embed="rIdFooter0"/>
+          <a:stretch xmlns:a="http://schemas.openxmlformats.org/drawingml/2006/main"/>
+        </p:blipFill>
+        <p:spPr>
+          <a:xfrm xmlns:a="http://schemas.openxmlformats.org/drawingml/2006/main">
+            <a:off x="391346" y="6191250"/>
+            <a:ext cx="998483" cy="542925"/>
+          </a:xfrm>
+          <a:prstGeom xmlns:a="http://schemas.openxmlformats.org/drawingml/2006/main" prst="rect">
+            <a:avLst/>
+          </a:prstGeom>
+        </p:spPr>
+      </p:pic>
+      <p:pic>
+        <p:nvPicPr>
+          <p:cNvPr id="24" name=""/>
+          <p:cNvPicPr>
+            <a:picLocks xmlns:a="http://schemas.openxmlformats.org/drawingml/2006/main" noChangeAspect="1"/>
+          </p:cNvPicPr>
+          <p:nvPr/>
+        </p:nvPicPr>
+        <p:blipFill>
+          <a:blip xmlns:r="http://schemas.openxmlformats.org/officeDocument/2006/relationships" xmlns:a="http://schemas.openxmlformats.org/drawingml/2006/main" r:embed="rIdFooter1"/>
+          <a:stretch xmlns:a="http://schemas.openxmlformats.org/drawingml/2006/main"/>
+        </p:blipFill>
+        <p:spPr>
+          <a:xfrm xmlns:a="http://schemas.openxmlformats.org/drawingml/2006/main">
+            <a:off x="1669256" y="6191250"/>
+            <a:ext cx="1300163" cy="542925"/>
+          </a:xfrm>
+          <a:prstGeom xmlns:a="http://schemas.openxmlformats.org/drawingml/2006/main" prst="rect">
+            <a:avLst/>
+          </a:prstGeom>
+        </p:spPr>
+      </p:pic>
     </p:spTree>
     <p:extLst>
       <p:ext uri="{BB962C8B-B14F-4D97-AF65-F5344CB8AC3E}">
@@ -13903,6 +14519,50 @@
           </a:p>
         </p:txBody>
       </p:sp>
+      <p:pic>
+        <p:nvPicPr>
+          <p:cNvPr id="534" name=""/>
+          <p:cNvPicPr>
+            <a:picLocks xmlns:a="http://schemas.openxmlformats.org/drawingml/2006/main" noChangeAspect="1"/>
+          </p:cNvPicPr>
+          <p:nvPr/>
+        </p:nvPicPr>
+        <p:blipFill>
+          <a:blip xmlns:r="http://schemas.openxmlformats.org/officeDocument/2006/relationships" xmlns:a="http://schemas.openxmlformats.org/drawingml/2006/main" r:embed="rIdFooter0"/>
+          <a:stretch xmlns:a="http://schemas.openxmlformats.org/drawingml/2006/main"/>
+        </p:blipFill>
+        <p:spPr>
+          <a:xfrm xmlns:a="http://schemas.openxmlformats.org/drawingml/2006/main">
+            <a:off x="391346" y="6191250"/>
+            <a:ext cx="998483" cy="542925"/>
+          </a:xfrm>
+          <a:prstGeom xmlns:a="http://schemas.openxmlformats.org/drawingml/2006/main" prst="rect">
+            <a:avLst/>
+          </a:prstGeom>
+        </p:spPr>
+      </p:pic>
+      <p:pic>
+        <p:nvPicPr>
+          <p:cNvPr id="535" name=""/>
+          <p:cNvPicPr>
+            <a:picLocks xmlns:a="http://schemas.openxmlformats.org/drawingml/2006/main" noChangeAspect="1"/>
+          </p:cNvPicPr>
+          <p:nvPr/>
+        </p:nvPicPr>
+        <p:blipFill>
+          <a:blip xmlns:r="http://schemas.openxmlformats.org/officeDocument/2006/relationships" xmlns:a="http://schemas.openxmlformats.org/drawingml/2006/main" r:embed="rIdFooter1"/>
+          <a:stretch xmlns:a="http://schemas.openxmlformats.org/drawingml/2006/main"/>
+        </p:blipFill>
+        <p:spPr>
+          <a:xfrm xmlns:a="http://schemas.openxmlformats.org/drawingml/2006/main">
+            <a:off x="1669256" y="6191250"/>
+            <a:ext cx="1300163" cy="542925"/>
+          </a:xfrm>
+          <a:prstGeom xmlns:a="http://schemas.openxmlformats.org/drawingml/2006/main" prst="rect">
+            <a:avLst/>
+          </a:prstGeom>
+        </p:spPr>
+      </p:pic>
     </p:spTree>
     <p:extLst>
       <p:ext uri="{BB962C8B-B14F-4D97-AF65-F5344CB8AC3E}">
@@ -14475,6 +15135,50 @@
           </a:p>
         </p:txBody>
       </p:sp>
+      <p:pic>
+        <p:nvPicPr>
+          <p:cNvPr id="12" name=""/>
+          <p:cNvPicPr>
+            <a:picLocks xmlns:a="http://schemas.openxmlformats.org/drawingml/2006/main" noChangeAspect="1"/>
+          </p:cNvPicPr>
+          <p:nvPr/>
+        </p:nvPicPr>
+        <p:blipFill>
+          <a:blip xmlns:r="http://schemas.openxmlformats.org/officeDocument/2006/relationships" xmlns:a="http://schemas.openxmlformats.org/drawingml/2006/main" r:embed="rIdFooter0"/>
+          <a:stretch xmlns:a="http://schemas.openxmlformats.org/drawingml/2006/main"/>
+        </p:blipFill>
+        <p:spPr>
+          <a:xfrm xmlns:a="http://schemas.openxmlformats.org/drawingml/2006/main">
+            <a:off x="391346" y="6191250"/>
+            <a:ext cx="998483" cy="542925"/>
+          </a:xfrm>
+          <a:prstGeom xmlns:a="http://schemas.openxmlformats.org/drawingml/2006/main" prst="rect">
+            <a:avLst/>
+          </a:prstGeom>
+        </p:spPr>
+      </p:pic>
+      <p:pic>
+        <p:nvPicPr>
+          <p:cNvPr id="13" name=""/>
+          <p:cNvPicPr>
+            <a:picLocks xmlns:a="http://schemas.openxmlformats.org/drawingml/2006/main" noChangeAspect="1"/>
+          </p:cNvPicPr>
+          <p:nvPr/>
+        </p:nvPicPr>
+        <p:blipFill>
+          <a:blip xmlns:r="http://schemas.openxmlformats.org/officeDocument/2006/relationships" xmlns:a="http://schemas.openxmlformats.org/drawingml/2006/main" r:embed="rIdFooter1"/>
+          <a:stretch xmlns:a="http://schemas.openxmlformats.org/drawingml/2006/main"/>
+        </p:blipFill>
+        <p:spPr>
+          <a:xfrm xmlns:a="http://schemas.openxmlformats.org/drawingml/2006/main">
+            <a:off x="1669256" y="6191250"/>
+            <a:ext cx="1300163" cy="542925"/>
+          </a:xfrm>
+          <a:prstGeom xmlns:a="http://schemas.openxmlformats.org/drawingml/2006/main" prst="rect">
+            <a:avLst/>
+          </a:prstGeom>
+        </p:spPr>
+      </p:pic>
     </p:spTree>
     <p:extLst>
       <p:ext uri="{BB962C8B-B14F-4D97-AF65-F5344CB8AC3E}">
@@ -15089,6 +15793,50 @@
           </a:p>
         </p:txBody>
       </p:sp>
+      <p:pic>
+        <p:nvPicPr>
+          <p:cNvPr id="534" name=""/>
+          <p:cNvPicPr>
+            <a:picLocks xmlns:a="http://schemas.openxmlformats.org/drawingml/2006/main" noChangeAspect="1"/>
+          </p:cNvPicPr>
+          <p:nvPr/>
+        </p:nvPicPr>
+        <p:blipFill>
+          <a:blip xmlns:r="http://schemas.openxmlformats.org/officeDocument/2006/relationships" xmlns:a="http://schemas.openxmlformats.org/drawingml/2006/main" r:embed="rIdFooter0"/>
+          <a:stretch xmlns:a="http://schemas.openxmlformats.org/drawingml/2006/main"/>
+        </p:blipFill>
+        <p:spPr>
+          <a:xfrm xmlns:a="http://schemas.openxmlformats.org/drawingml/2006/main">
+            <a:off x="391346" y="6191250"/>
+            <a:ext cx="998483" cy="542925"/>
+          </a:xfrm>
+          <a:prstGeom xmlns:a="http://schemas.openxmlformats.org/drawingml/2006/main" prst="rect">
+            <a:avLst/>
+          </a:prstGeom>
+        </p:spPr>
+      </p:pic>
+      <p:pic>
+        <p:nvPicPr>
+          <p:cNvPr id="535" name=""/>
+          <p:cNvPicPr>
+            <a:picLocks xmlns:a="http://schemas.openxmlformats.org/drawingml/2006/main" noChangeAspect="1"/>
+          </p:cNvPicPr>
+          <p:nvPr/>
+        </p:nvPicPr>
+        <p:blipFill>
+          <a:blip xmlns:r="http://schemas.openxmlformats.org/officeDocument/2006/relationships" xmlns:a="http://schemas.openxmlformats.org/drawingml/2006/main" r:embed="rIdFooter1"/>
+          <a:stretch xmlns:a="http://schemas.openxmlformats.org/drawingml/2006/main"/>
+        </p:blipFill>
+        <p:spPr>
+          <a:xfrm xmlns:a="http://schemas.openxmlformats.org/drawingml/2006/main">
+            <a:off x="1669256" y="6191250"/>
+            <a:ext cx="1300163" cy="542925"/>
+          </a:xfrm>
+          <a:prstGeom xmlns:a="http://schemas.openxmlformats.org/drawingml/2006/main" prst="rect">
+            <a:avLst/>
+          </a:prstGeom>
+        </p:spPr>
+      </p:pic>
     </p:spTree>
     <p:extLst>
       <p:ext uri="{BB962C8B-B14F-4D97-AF65-F5344CB8AC3E}">

</xml_diff>